<commit_message>
Append supplementary discussion slides to the consultation deck
Builds on the author's edited version (slides 1-6 unchanged) and adds
four plain slides: study aim and age effect, the opt-out notice scope,
reporting deviations, and additional questions for the professor.

Co-Authored-By: Claude Opus 5.5 <noreply@anthropic.com>
Claude-Session: https://claude.ai/code/session_01T8aUdDvzJgmNMrwQiwRrvV
</commit_message>
<xml_diff>
--- a/manuscripts/P01_pancreatic_cancer_CRT_immunity/materials/教授相談_対象症例の確認_20261019.pptx
+++ b/manuscripts/P01_pancreatic_cancer_CRT_immunity/materials/教授相談_対象症例の確認_20261019.pptx
@@ -5,14 +5,18 @@
     <p:sldMasterId id="2147483648" r:id="rId1"/>
   </p:sldMasterIdLst>
   <p:sldIdLst>
-    <p:sldId id="256" r:id="rId7"/>
-    <p:sldId id="257" r:id="rId8"/>
-    <p:sldId id="258" r:id="rId9"/>
-    <p:sldId id="259" r:id="rId10"/>
-    <p:sldId id="260" r:id="rId11"/>
-    <p:sldId id="261" r:id="rId12"/>
+    <p:sldId id="256" r:id="rId2"/>
+    <p:sldId id="257" r:id="rId3"/>
+    <p:sldId id="258" r:id="rId4"/>
+    <p:sldId id="259" r:id="rId5"/>
+    <p:sldId id="260" r:id="rId6"/>
+    <p:sldId id="261" r:id="rId7"/>
+    <p:sldId id="262" r:id="rId13"/>
+    <p:sldId id="263" r:id="rId14"/>
+    <p:sldId id="264" r:id="rId15"/>
+    <p:sldId id="265" r:id="rId16"/>
   </p:sldIdLst>
-  <p:sldSz cx="12191695" cy="6858000" type="screen4x3"/>
+  <p:sldSz cx="12192000" cy="6858000"/>
   <p:notesSz cx="6858000" cy="9144000"/>
   <p:defaultTextStyle>
     <a:defPPr>
@@ -109,7 +113,67 @@
       </a:defRPr>
     </a:lvl9pPr>
   </p:defaultTextStyle>
+  <p:extLst>
+    <p:ext uri="{EFAFB233-063F-42B5-8137-9DF3F51BA10A}">
+      <p15:sldGuideLst xmlns:p15="http://schemas.microsoft.com/office/powerpoint/2012/main">
+        <p15:guide id="1" orient="horz" pos="2160">
+          <p15:clr>
+            <a:srgbClr val="A4A3A4"/>
+          </p15:clr>
+        </p15:guide>
+        <p15:guide id="2" pos="2880">
+          <p15:clr>
+            <a:srgbClr val="A4A3A4"/>
+          </p15:clr>
+        </p15:guide>
+      </p15:sldGuideLst>
+    </p:ext>
+  </p:extLst>
 </p:presentation>
+</file>
+
+<file path=ppt/changesInfos/changesInfo1.xml><?xml version="1.0" encoding="utf-8"?>
+<pc:chgInfo xmlns:a="http://schemas.openxmlformats.org/drawingml/2006/main" xmlns:r="http://schemas.openxmlformats.org/officeDocument/2006/relationships" xmlns:ac="http://schemas.microsoft.com/office/drawing/2013/main/command" xmlns:pc="http://schemas.microsoft.com/office/powerpoint/2013/main/command">
+  <pc:docChgLst>
+    <pc:chgData name="和真 梅宮" userId="b9b0d45eea3f0a9d" providerId="LiveId" clId="{1D82322B-B29B-4D33-BD9A-8F27EB04CACA}"/>
+    <pc:docChg chg="modSld">
+      <pc:chgData name="和真 梅宮" userId="b9b0d45eea3f0a9d" providerId="LiveId" clId="{1D82322B-B29B-4D33-BD9A-8F27EB04CACA}" dt="2026-10-19T14:15:14.598" v="338"/>
+      <pc:docMkLst>
+        <pc:docMk/>
+      </pc:docMkLst>
+      <pc:sldChg chg="modSp mod">
+        <pc:chgData name="和真 梅宮" userId="b9b0d45eea3f0a9d" providerId="LiveId" clId="{1D82322B-B29B-4D33-BD9A-8F27EB04CACA}" dt="2026-10-19T14:12:34.666" v="49"/>
+        <pc:sldMkLst>
+          <pc:docMk/>
+          <pc:sldMk cId="0" sldId="259"/>
+        </pc:sldMkLst>
+        <pc:spChg chg="mod">
+          <ac:chgData name="和真 梅宮" userId="b9b0d45eea3f0a9d" providerId="LiveId" clId="{1D82322B-B29B-4D33-BD9A-8F27EB04CACA}" dt="2026-10-19T14:12:34.666" v="49"/>
+          <ac:spMkLst>
+            <pc:docMk/>
+            <pc:sldMk cId="0" sldId="259"/>
+            <ac:spMk id="3" creationId="{00000000-0000-0000-0000-000000000000}"/>
+          </ac:spMkLst>
+        </pc:spChg>
+      </pc:sldChg>
+      <pc:sldChg chg="modSp mod">
+        <pc:chgData name="和真 梅宮" userId="b9b0d45eea3f0a9d" providerId="LiveId" clId="{1D82322B-B29B-4D33-BD9A-8F27EB04CACA}" dt="2026-10-19T14:15:14.598" v="338"/>
+        <pc:sldMkLst>
+          <pc:docMk/>
+          <pc:sldMk cId="0" sldId="261"/>
+        </pc:sldMkLst>
+        <pc:spChg chg="mod">
+          <ac:chgData name="和真 梅宮" userId="b9b0d45eea3f0a9d" providerId="LiveId" clId="{1D82322B-B29B-4D33-BD9A-8F27EB04CACA}" dt="2026-10-19T14:15:14.598" v="338"/>
+          <ac:spMkLst>
+            <pc:docMk/>
+            <pc:sldMk cId="0" sldId="261"/>
+            <ac:spMk id="3" creationId="{00000000-0000-0000-0000-000000000000}"/>
+          </ac:spMkLst>
+        </pc:spChg>
+      </pc:sldChg>
+    </pc:docChg>
+  </pc:docChgLst>
+</pc:chgInfo>
 </file>
 
 <file path=ppt/slideLayouts/slideLayout1.xml><?xml version="1.0" encoding="utf-8"?>
@@ -150,10 +214,9 @@
           <a:lstStyle/>
           <a:p>
             <a:r>
-              <a:rPr lang="en-US" smtClean="0"/>
+              <a:rPr lang="en-US"/>
               <a:t>Click to edit Master title style</a:t>
             </a:r>
-            <a:endParaRPr lang="en-US"/>
           </a:p>
         </p:txBody>
       </p:sp>
@@ -269,10 +332,9 @@
           </a:lstStyle>
           <a:p>
             <a:r>
-              <a:rPr lang="en-US" smtClean="0"/>
+              <a:rPr lang="en-US"/>
               <a:t>Click to edit Master subtitle style</a:t>
             </a:r>
-            <a:endParaRPr lang="en-US"/>
           </a:p>
         </p:txBody>
       </p:sp>
@@ -293,7 +355,7 @@
           <a:p>
             <a:fld id="{5BCAD085-E8A6-8845-BD4E-CB4CCA059FC4}" type="datetimeFigureOut">
               <a:rPr lang="en-US" smtClean="0"/>
-              <a:t>1/27/13</a:t>
+              <a:t>10/19/2026</a:t>
             </a:fld>
             <a:endParaRPr lang="en-US"/>
           </a:p>
@@ -387,10 +449,9 @@
           <a:lstStyle/>
           <a:p>
             <a:r>
-              <a:rPr lang="en-US" smtClean="0"/>
+              <a:rPr lang="en-US"/>
               <a:t>Click to edit Master title style</a:t>
             </a:r>
-            <a:endParaRPr lang="en-US"/>
           </a:p>
         </p:txBody>
       </p:sp>
@@ -411,38 +472,37 @@
           <a:p>
             <a:pPr lvl="0"/>
             <a:r>
-              <a:rPr lang="en-US" smtClean="0"/>
+              <a:rPr lang="en-US"/>
               <a:t>Click to edit Master text styles</a:t>
             </a:r>
           </a:p>
           <a:p>
             <a:pPr lvl="1"/>
             <a:r>
-              <a:rPr lang="en-US" smtClean="0"/>
+              <a:rPr lang="en-US"/>
               <a:t>Second level</a:t>
             </a:r>
           </a:p>
           <a:p>
             <a:pPr lvl="2"/>
             <a:r>
-              <a:rPr lang="en-US" smtClean="0"/>
+              <a:rPr lang="en-US"/>
               <a:t>Third level</a:t>
             </a:r>
           </a:p>
           <a:p>
             <a:pPr lvl="3"/>
             <a:r>
-              <a:rPr lang="en-US" smtClean="0"/>
+              <a:rPr lang="en-US"/>
               <a:t>Fourth level</a:t>
             </a:r>
           </a:p>
           <a:p>
             <a:pPr lvl="4"/>
             <a:r>
-              <a:rPr lang="en-US" smtClean="0"/>
+              <a:rPr lang="en-US"/>
               <a:t>Fifth level</a:t>
             </a:r>
-            <a:endParaRPr lang="en-US"/>
           </a:p>
         </p:txBody>
       </p:sp>
@@ -463,7 +523,7 @@
           <a:p>
             <a:fld id="{5BCAD085-E8A6-8845-BD4E-CB4CCA059FC4}" type="datetimeFigureOut">
               <a:rPr lang="en-US" smtClean="0"/>
-              <a:t>1/27/13</a:t>
+              <a:t>10/19/2026</a:t>
             </a:fld>
             <a:endParaRPr lang="en-US"/>
           </a:p>
@@ -562,10 +622,9 @@
           <a:lstStyle/>
           <a:p>
             <a:r>
-              <a:rPr lang="en-US" smtClean="0"/>
+              <a:rPr lang="en-US"/>
               <a:t>Click to edit Master title style</a:t>
             </a:r>
-            <a:endParaRPr lang="en-US"/>
           </a:p>
         </p:txBody>
       </p:sp>
@@ -591,38 +650,37 @@
           <a:p>
             <a:pPr lvl="0"/>
             <a:r>
-              <a:rPr lang="en-US" smtClean="0"/>
+              <a:rPr lang="en-US"/>
               <a:t>Click to edit Master text styles</a:t>
             </a:r>
           </a:p>
           <a:p>
             <a:pPr lvl="1"/>
             <a:r>
-              <a:rPr lang="en-US" smtClean="0"/>
+              <a:rPr lang="en-US"/>
               <a:t>Second level</a:t>
             </a:r>
           </a:p>
           <a:p>
             <a:pPr lvl="2"/>
             <a:r>
-              <a:rPr lang="en-US" smtClean="0"/>
+              <a:rPr lang="en-US"/>
               <a:t>Third level</a:t>
             </a:r>
           </a:p>
           <a:p>
             <a:pPr lvl="3"/>
             <a:r>
-              <a:rPr lang="en-US" smtClean="0"/>
+              <a:rPr lang="en-US"/>
               <a:t>Fourth level</a:t>
             </a:r>
           </a:p>
           <a:p>
             <a:pPr lvl="4"/>
             <a:r>
-              <a:rPr lang="en-US" smtClean="0"/>
+              <a:rPr lang="en-US"/>
               <a:t>Fifth level</a:t>
             </a:r>
-            <a:endParaRPr lang="en-US"/>
           </a:p>
         </p:txBody>
       </p:sp>
@@ -643,7 +701,7 @@
           <a:p>
             <a:fld id="{5BCAD085-E8A6-8845-BD4E-CB4CCA059FC4}" type="datetimeFigureOut">
               <a:rPr lang="en-US" smtClean="0"/>
-              <a:t>1/27/13</a:t>
+              <a:t>10/19/2026</a:t>
             </a:fld>
             <a:endParaRPr lang="en-US"/>
           </a:p>
@@ -737,10 +795,9 @@
           <a:lstStyle/>
           <a:p>
             <a:r>
-              <a:rPr lang="en-US" smtClean="0"/>
+              <a:rPr lang="en-US"/>
               <a:t>Click to edit Master title style</a:t>
             </a:r>
-            <a:endParaRPr lang="en-US"/>
           </a:p>
         </p:txBody>
       </p:sp>
@@ -761,38 +818,37 @@
           <a:p>
             <a:pPr lvl="0"/>
             <a:r>
-              <a:rPr lang="en-US" smtClean="0"/>
+              <a:rPr lang="en-US"/>
               <a:t>Click to edit Master text styles</a:t>
             </a:r>
           </a:p>
           <a:p>
             <a:pPr lvl="1"/>
             <a:r>
-              <a:rPr lang="en-US" smtClean="0"/>
+              <a:rPr lang="en-US"/>
               <a:t>Second level</a:t>
             </a:r>
           </a:p>
           <a:p>
             <a:pPr lvl="2"/>
             <a:r>
-              <a:rPr lang="en-US" smtClean="0"/>
+              <a:rPr lang="en-US"/>
               <a:t>Third level</a:t>
             </a:r>
           </a:p>
           <a:p>
             <a:pPr lvl="3"/>
             <a:r>
-              <a:rPr lang="en-US" smtClean="0"/>
+              <a:rPr lang="en-US"/>
               <a:t>Fourth level</a:t>
             </a:r>
           </a:p>
           <a:p>
             <a:pPr lvl="4"/>
             <a:r>
-              <a:rPr lang="en-US" smtClean="0"/>
+              <a:rPr lang="en-US"/>
               <a:t>Fifth level</a:t>
             </a:r>
-            <a:endParaRPr lang="en-US"/>
           </a:p>
         </p:txBody>
       </p:sp>
@@ -813,7 +869,7 @@
           <a:p>
             <a:fld id="{5BCAD085-E8A6-8845-BD4E-CB4CCA059FC4}" type="datetimeFigureOut">
               <a:rPr lang="en-US" smtClean="0"/>
-              <a:t>1/27/13</a:t>
+              <a:t>10/19/2026</a:t>
             </a:fld>
             <a:endParaRPr lang="en-US"/>
           </a:p>
@@ -916,10 +972,9 @@
           </a:lstStyle>
           <a:p>
             <a:r>
-              <a:rPr lang="en-US" smtClean="0"/>
+              <a:rPr lang="en-US"/>
               <a:t>Click to edit Master title style</a:t>
             </a:r>
-            <a:endParaRPr lang="en-US"/>
           </a:p>
         </p:txBody>
       </p:sp>
@@ -1036,7 +1091,7 @@
           <a:p>
             <a:pPr lvl="0"/>
             <a:r>
-              <a:rPr lang="en-US" smtClean="0"/>
+              <a:rPr lang="en-US"/>
               <a:t>Click to edit Master text styles</a:t>
             </a:r>
           </a:p>
@@ -1059,7 +1114,7 @@
           <a:p>
             <a:fld id="{5BCAD085-E8A6-8845-BD4E-CB4CCA059FC4}" type="datetimeFigureOut">
               <a:rPr lang="en-US" smtClean="0"/>
-              <a:t>1/27/13</a:t>
+              <a:t>10/19/2026</a:t>
             </a:fld>
             <a:endParaRPr lang="en-US"/>
           </a:p>
@@ -1153,10 +1208,9 @@
           <a:lstStyle/>
           <a:p>
             <a:r>
-              <a:rPr lang="en-US" smtClean="0"/>
+              <a:rPr lang="en-US"/>
               <a:t>Click to edit Master title style</a:t>
             </a:r>
-            <a:endParaRPr lang="en-US"/>
           </a:p>
         </p:txBody>
       </p:sp>
@@ -1210,38 +1264,37 @@
           <a:p>
             <a:pPr lvl="0"/>
             <a:r>
-              <a:rPr lang="en-US" smtClean="0"/>
+              <a:rPr lang="en-US"/>
               <a:t>Click to edit Master text styles</a:t>
             </a:r>
           </a:p>
           <a:p>
             <a:pPr lvl="1"/>
             <a:r>
-              <a:rPr lang="en-US" smtClean="0"/>
+              <a:rPr lang="en-US"/>
               <a:t>Second level</a:t>
             </a:r>
           </a:p>
           <a:p>
             <a:pPr lvl="2"/>
             <a:r>
-              <a:rPr lang="en-US" smtClean="0"/>
+              <a:rPr lang="en-US"/>
               <a:t>Third level</a:t>
             </a:r>
           </a:p>
           <a:p>
             <a:pPr lvl="3"/>
             <a:r>
-              <a:rPr lang="en-US" smtClean="0"/>
+              <a:rPr lang="en-US"/>
               <a:t>Fourth level</a:t>
             </a:r>
           </a:p>
           <a:p>
             <a:pPr lvl="4"/>
             <a:r>
-              <a:rPr lang="en-US" smtClean="0"/>
+              <a:rPr lang="en-US"/>
               <a:t>Fifth level</a:t>
             </a:r>
-            <a:endParaRPr lang="en-US"/>
           </a:p>
         </p:txBody>
       </p:sp>
@@ -1295,38 +1348,37 @@
           <a:p>
             <a:pPr lvl="0"/>
             <a:r>
-              <a:rPr lang="en-US" smtClean="0"/>
+              <a:rPr lang="en-US"/>
               <a:t>Click to edit Master text styles</a:t>
             </a:r>
           </a:p>
           <a:p>
             <a:pPr lvl="1"/>
             <a:r>
-              <a:rPr lang="en-US" smtClean="0"/>
+              <a:rPr lang="en-US"/>
               <a:t>Second level</a:t>
             </a:r>
           </a:p>
           <a:p>
             <a:pPr lvl="2"/>
             <a:r>
-              <a:rPr lang="en-US" smtClean="0"/>
+              <a:rPr lang="en-US"/>
               <a:t>Third level</a:t>
             </a:r>
           </a:p>
           <a:p>
             <a:pPr lvl="3"/>
             <a:r>
-              <a:rPr lang="en-US" smtClean="0"/>
+              <a:rPr lang="en-US"/>
               <a:t>Fourth level</a:t>
             </a:r>
           </a:p>
           <a:p>
             <a:pPr lvl="4"/>
             <a:r>
-              <a:rPr lang="en-US" smtClean="0"/>
+              <a:rPr lang="en-US"/>
               <a:t>Fifth level</a:t>
             </a:r>
-            <a:endParaRPr lang="en-US"/>
           </a:p>
         </p:txBody>
       </p:sp>
@@ -1347,7 +1399,7 @@
           <a:p>
             <a:fld id="{5BCAD085-E8A6-8845-BD4E-CB4CCA059FC4}" type="datetimeFigureOut">
               <a:rPr lang="en-US" smtClean="0"/>
-              <a:t>1/27/13</a:t>
+              <a:t>10/19/2026</a:t>
             </a:fld>
             <a:endParaRPr lang="en-US"/>
           </a:p>
@@ -1445,10 +1497,9 @@
           </a:lstStyle>
           <a:p>
             <a:r>
-              <a:rPr lang="en-US" smtClean="0"/>
+              <a:rPr lang="en-US"/>
               <a:t>Click to edit Master title style</a:t>
             </a:r>
-            <a:endParaRPr lang="en-US"/>
           </a:p>
         </p:txBody>
       </p:sp>
@@ -1511,7 +1562,7 @@
           <a:p>
             <a:pPr lvl="0"/>
             <a:r>
-              <a:rPr lang="en-US" smtClean="0"/>
+              <a:rPr lang="en-US"/>
               <a:t>Click to edit Master text styles</a:t>
             </a:r>
           </a:p>
@@ -1567,38 +1618,37 @@
           <a:p>
             <a:pPr lvl="0"/>
             <a:r>
-              <a:rPr lang="en-US" smtClean="0"/>
+              <a:rPr lang="en-US"/>
               <a:t>Click to edit Master text styles</a:t>
             </a:r>
           </a:p>
           <a:p>
             <a:pPr lvl="1"/>
             <a:r>
-              <a:rPr lang="en-US" smtClean="0"/>
+              <a:rPr lang="en-US"/>
               <a:t>Second level</a:t>
             </a:r>
           </a:p>
           <a:p>
             <a:pPr lvl="2"/>
             <a:r>
-              <a:rPr lang="en-US" smtClean="0"/>
+              <a:rPr lang="en-US"/>
               <a:t>Third level</a:t>
             </a:r>
           </a:p>
           <a:p>
             <a:pPr lvl="3"/>
             <a:r>
-              <a:rPr lang="en-US" smtClean="0"/>
+              <a:rPr lang="en-US"/>
               <a:t>Fourth level</a:t>
             </a:r>
           </a:p>
           <a:p>
             <a:pPr lvl="4"/>
             <a:r>
-              <a:rPr lang="en-US" smtClean="0"/>
+              <a:rPr lang="en-US"/>
               <a:t>Fifth level</a:t>
             </a:r>
-            <a:endParaRPr lang="en-US"/>
           </a:p>
         </p:txBody>
       </p:sp>
@@ -1661,7 +1711,7 @@
           <a:p>
             <a:pPr lvl="0"/>
             <a:r>
-              <a:rPr lang="en-US" smtClean="0"/>
+              <a:rPr lang="en-US"/>
               <a:t>Click to edit Master text styles</a:t>
             </a:r>
           </a:p>
@@ -1717,38 +1767,37 @@
           <a:p>
             <a:pPr lvl="0"/>
             <a:r>
-              <a:rPr lang="en-US" smtClean="0"/>
+              <a:rPr lang="en-US"/>
               <a:t>Click to edit Master text styles</a:t>
             </a:r>
           </a:p>
           <a:p>
             <a:pPr lvl="1"/>
             <a:r>
-              <a:rPr lang="en-US" smtClean="0"/>
+              <a:rPr lang="en-US"/>
               <a:t>Second level</a:t>
             </a:r>
           </a:p>
           <a:p>
             <a:pPr lvl="2"/>
             <a:r>
-              <a:rPr lang="en-US" smtClean="0"/>
+              <a:rPr lang="en-US"/>
               <a:t>Third level</a:t>
             </a:r>
           </a:p>
           <a:p>
             <a:pPr lvl="3"/>
             <a:r>
-              <a:rPr lang="en-US" smtClean="0"/>
+              <a:rPr lang="en-US"/>
               <a:t>Fourth level</a:t>
             </a:r>
           </a:p>
           <a:p>
             <a:pPr lvl="4"/>
             <a:r>
-              <a:rPr lang="en-US" smtClean="0"/>
+              <a:rPr lang="en-US"/>
               <a:t>Fifth level</a:t>
             </a:r>
-            <a:endParaRPr lang="en-US"/>
           </a:p>
         </p:txBody>
       </p:sp>
@@ -1769,7 +1818,7 @@
           <a:p>
             <a:fld id="{5BCAD085-E8A6-8845-BD4E-CB4CCA059FC4}" type="datetimeFigureOut">
               <a:rPr lang="en-US" smtClean="0"/>
-              <a:t>1/27/13</a:t>
+              <a:t>10/19/2026</a:t>
             </a:fld>
             <a:endParaRPr lang="en-US"/>
           </a:p>
@@ -1863,10 +1912,9 @@
           <a:lstStyle/>
           <a:p>
             <a:r>
-              <a:rPr lang="en-US" smtClean="0"/>
+              <a:rPr lang="en-US"/>
               <a:t>Click to edit Master title style</a:t>
             </a:r>
-            <a:endParaRPr lang="en-US"/>
           </a:p>
         </p:txBody>
       </p:sp>
@@ -1887,7 +1935,7 @@
           <a:p>
             <a:fld id="{5BCAD085-E8A6-8845-BD4E-CB4CCA059FC4}" type="datetimeFigureOut">
               <a:rPr lang="en-US" smtClean="0"/>
-              <a:t>1/27/13</a:t>
+              <a:t>10/19/2026</a:t>
             </a:fld>
             <a:endParaRPr lang="en-US"/>
           </a:p>
@@ -1982,7 +2030,7 @@
           <a:p>
             <a:fld id="{5BCAD085-E8A6-8845-BD4E-CB4CCA059FC4}" type="datetimeFigureOut">
               <a:rPr lang="en-US" smtClean="0"/>
-              <a:t>1/27/13</a:t>
+              <a:t>10/19/2026</a:t>
             </a:fld>
             <a:endParaRPr lang="en-US"/>
           </a:p>
@@ -2085,10 +2133,9 @@
           </a:lstStyle>
           <a:p>
             <a:r>
-              <a:rPr lang="en-US" smtClean="0"/>
+              <a:rPr lang="en-US"/>
               <a:t>Click to edit Master title style</a:t>
             </a:r>
-            <a:endParaRPr lang="en-US"/>
           </a:p>
         </p:txBody>
       </p:sp>
@@ -2142,38 +2189,37 @@
           <a:p>
             <a:pPr lvl="0"/>
             <a:r>
-              <a:rPr lang="en-US" smtClean="0"/>
+              <a:rPr lang="en-US"/>
               <a:t>Click to edit Master text styles</a:t>
             </a:r>
           </a:p>
           <a:p>
             <a:pPr lvl="1"/>
             <a:r>
-              <a:rPr lang="en-US" smtClean="0"/>
+              <a:rPr lang="en-US"/>
               <a:t>Second level</a:t>
             </a:r>
           </a:p>
           <a:p>
             <a:pPr lvl="2"/>
             <a:r>
-              <a:rPr lang="en-US" smtClean="0"/>
+              <a:rPr lang="en-US"/>
               <a:t>Third level</a:t>
             </a:r>
           </a:p>
           <a:p>
             <a:pPr lvl="3"/>
             <a:r>
-              <a:rPr lang="en-US" smtClean="0"/>
+              <a:rPr lang="en-US"/>
               <a:t>Fourth level</a:t>
             </a:r>
           </a:p>
           <a:p>
             <a:pPr lvl="4"/>
             <a:r>
-              <a:rPr lang="en-US" smtClean="0"/>
+              <a:rPr lang="en-US"/>
               <a:t>Fifth level</a:t>
             </a:r>
-            <a:endParaRPr lang="en-US"/>
           </a:p>
         </p:txBody>
       </p:sp>
@@ -2236,7 +2282,7 @@
           <a:p>
             <a:pPr lvl="0"/>
             <a:r>
-              <a:rPr lang="en-US" smtClean="0"/>
+              <a:rPr lang="en-US"/>
               <a:t>Click to edit Master text styles</a:t>
             </a:r>
           </a:p>
@@ -2259,7 +2305,7 @@
           <a:p>
             <a:fld id="{5BCAD085-E8A6-8845-BD4E-CB4CCA059FC4}" type="datetimeFigureOut">
               <a:rPr lang="en-US" smtClean="0"/>
-              <a:t>1/27/13</a:t>
+              <a:t>10/19/2026</a:t>
             </a:fld>
             <a:endParaRPr lang="en-US"/>
           </a:p>
@@ -2362,10 +2408,9 @@
           </a:lstStyle>
           <a:p>
             <a:r>
-              <a:rPr lang="en-US" smtClean="0"/>
+              <a:rPr lang="en-US"/>
               <a:t>Click to edit Master title style</a:t>
             </a:r>
-            <a:endParaRPr lang="en-US"/>
           </a:p>
         </p:txBody>
       </p:sp>
@@ -2489,7 +2534,7 @@
           <a:p>
             <a:pPr lvl="0"/>
             <a:r>
-              <a:rPr lang="en-US" smtClean="0"/>
+              <a:rPr lang="en-US"/>
               <a:t>Click to edit Master text styles</a:t>
             </a:r>
           </a:p>
@@ -2512,7 +2557,7 @@
           <a:p>
             <a:fld id="{5BCAD085-E8A6-8845-BD4E-CB4CCA059FC4}" type="datetimeFigureOut">
               <a:rPr lang="en-US" smtClean="0"/>
-              <a:t>1/27/13</a:t>
+              <a:t>10/19/2026</a:t>
             </a:fld>
             <a:endParaRPr lang="en-US"/>
           </a:p>
@@ -2621,10 +2666,9 @@
           <a:lstStyle/>
           <a:p>
             <a:r>
-              <a:rPr lang="en-US" smtClean="0"/>
+              <a:rPr lang="en-US"/>
               <a:t>Click to edit Master title style</a:t>
             </a:r>
-            <a:endParaRPr lang="en-US"/>
           </a:p>
         </p:txBody>
       </p:sp>
@@ -2655,38 +2699,37 @@
           <a:p>
             <a:pPr lvl="0"/>
             <a:r>
-              <a:rPr lang="en-US" smtClean="0"/>
+              <a:rPr lang="en-US"/>
               <a:t>Click to edit Master text styles</a:t>
             </a:r>
           </a:p>
           <a:p>
             <a:pPr lvl="1"/>
             <a:r>
-              <a:rPr lang="en-US" smtClean="0"/>
+              <a:rPr lang="en-US"/>
               <a:t>Second level</a:t>
             </a:r>
           </a:p>
           <a:p>
             <a:pPr lvl="2"/>
             <a:r>
-              <a:rPr lang="en-US" smtClean="0"/>
+              <a:rPr lang="en-US"/>
               <a:t>Third level</a:t>
             </a:r>
           </a:p>
           <a:p>
             <a:pPr lvl="3"/>
             <a:r>
-              <a:rPr lang="en-US" smtClean="0"/>
+              <a:rPr lang="en-US"/>
               <a:t>Fourth level</a:t>
             </a:r>
           </a:p>
           <a:p>
             <a:pPr lvl="4"/>
             <a:r>
-              <a:rPr lang="en-US" smtClean="0"/>
+              <a:rPr lang="en-US"/>
               <a:t>Fifth level</a:t>
             </a:r>
-            <a:endParaRPr lang="en-US"/>
           </a:p>
         </p:txBody>
       </p:sp>
@@ -2725,7 +2768,7 @@
           <a:p>
             <a:fld id="{5BCAD085-E8A6-8845-BD4E-CB4CCA059FC4}" type="datetimeFigureOut">
               <a:rPr lang="en-US" smtClean="0"/>
-              <a:t>1/27/13</a:t>
+              <a:t>10/19/2026</a:t>
             </a:fld>
             <a:endParaRPr lang="en-US"/>
           </a:p>
@@ -3084,7 +3127,7 @@
 </file>
 
 <file path=ppt/slides/slide1.xml><?xml version="1.0" encoding="utf-8"?>
-<p:sld xmlns:a="http://schemas.openxmlformats.org/drawingml/2006/main" xmlns:p="http://schemas.openxmlformats.org/presentationml/2006/main" xmlns:r="http://schemas.openxmlformats.org/officeDocument/2006/relationships">
+<p:sld xmlns:a="http://schemas.openxmlformats.org/drawingml/2006/main" xmlns:r="http://schemas.openxmlformats.org/officeDocument/2006/relationships" xmlns:p="http://schemas.openxmlformats.org/presentationml/2006/main">
   <p:cSld>
     <p:spTree>
       <p:nvGrpSpPr>
@@ -3092,7 +3135,14 @@
         <p:cNvGrpSpPr/>
         <p:nvPr/>
       </p:nvGrpSpPr>
-      <p:grpSpPr/>
+      <p:grpSpPr>
+        <a:xfrm>
+          <a:off x="0" y="0"/>
+          <a:ext cx="0" cy="0"/>
+          <a:chOff x="0" y="0"/>
+          <a:chExt cx="0" cy="0"/>
+        </a:xfrm>
+      </p:grpSpPr>
       <p:sp>
         <p:nvSpPr>
           <p:cNvPr id="2" name="TextBox 1"/>
@@ -3110,7 +3160,7 @@
           <a:noFill/>
         </p:spPr>
         <p:txBody>
-          <a:bodyPr wrap="square" anchor="t" lIns="0" rIns="0">
+          <a:bodyPr wrap="square" lIns="0" rIns="0" anchor="t">
             <a:spAutoFit/>
           </a:bodyPr>
           <a:lstStyle/>
@@ -3124,7 +3174,7 @@
               </a:spcAft>
             </a:pPr>
             <a:r>
-              <a:rPr sz="3600" b="0" lang="ja-JP" altLang="en-US">
+              <a:rPr lang="ja-JP" altLang="en-US" sz="3600" b="0">
                 <a:solidFill>
                   <a:srgbClr val="000000"/>
                 </a:solidFill>
@@ -3153,7 +3203,7 @@
           <a:noFill/>
         </p:spPr>
         <p:txBody>
-          <a:bodyPr wrap="square" anchor="t" lIns="0" rIns="0">
+          <a:bodyPr wrap="square" lIns="0" rIns="0" anchor="t">
             <a:spAutoFit/>
           </a:bodyPr>
           <a:lstStyle/>
@@ -3167,7 +3217,7 @@
               </a:spcAft>
             </a:pPr>
             <a:r>
-              <a:rPr sz="2000" b="0" lang="ja-JP" altLang="en-US">
+              <a:rPr lang="ja-JP" altLang="en-US" sz="2000" b="0">
                 <a:solidFill>
                   <a:srgbClr val="000000"/>
                 </a:solidFill>
@@ -3187,7 +3237,7 @@
               </a:spcAft>
             </a:pPr>
             <a:r>
-              <a:rPr sz="2000" b="0" lang="ja-JP" altLang="en-US">
+              <a:rPr lang="ja-JP" altLang="en-US" sz="2000" b="0">
                 <a:solidFill>
                   <a:srgbClr val="000000"/>
                 </a:solidFill>
@@ -3207,7 +3257,7 @@
 </p:sld>
 </file>
 
-<file path=ppt/slides/slide2.xml><?xml version="1.0" encoding="utf-8"?>
+<file path=ppt/slides/slide10.xml><?xml version="1.0" encoding="utf-8"?>
 <p:sld xmlns:a="http://schemas.openxmlformats.org/drawingml/2006/main" xmlns:p="http://schemas.openxmlformats.org/presentationml/2006/main" xmlns:r="http://schemas.openxmlformats.org/officeDocument/2006/relationships">
   <p:cSld>
     <p:spTree>
@@ -3255,7 +3305,7 @@
                 <a:latin typeface="Yu Gothic"/>
                 <a:ea typeface="Yu Gothic"/>
               </a:rPr>
-              <a:t>現在の解析対象</a:t>
+              <a:t>補足のご相談</a:t>
             </a:r>
           </a:p>
         </p:txBody>
@@ -3298,7 +3348,7 @@
                 <a:latin typeface="Yu Gothic"/>
                 <a:ea typeface="Yu Gothic"/>
               </a:rPr>
-              <a:t>期間中に膵癌で切除術を受けた106例のうち、術前治療の内容が異なる8例、組織切片が入手できなかった8例、浸潤性膵管癌以外の組織型であった4例を除外した。</a:t>
+              <a:t>1．研究計画書との一致は、論文化の絶対要件か。</a:t>
             </a:r>
           </a:p>
           <a:p>
@@ -3318,7 +3368,27 @@
                 <a:latin typeface="Yu Gothic"/>
                 <a:ea typeface="Yu Gothic"/>
               </a:rPr>
-              <a:t>解析対象は86例（NACRT群24例、手術単独群62例）である。SF055はカルテでNACRT施行を確認し、NACRT群に含めた。</a:t>
+              <a:t>2．研究終了後でも、逸脱の報告や施設への相談は可能か。</a:t>
+            </a:r>
+          </a:p>
+          <a:p>
+            <a:pPr algn="l" eaLnBrk="1" hangingPunct="1">
+              <a:lnSpc>
+                <a:spcPct val="130000"/>
+              </a:lnSpc>
+              <a:spcAft>
+                <a:spcPts val="1800"/>
+              </a:spcAft>
+            </a:pPr>
+            <a:r>
+              <a:rPr sz="2200" b="0" lang="ja-JP" altLang="en-US">
+                <a:solidFill>
+                  <a:srgbClr val="000000"/>
+                </a:solidFill>
+                <a:latin typeface="Yu Gothic"/>
+                <a:ea typeface="Yu Gothic"/>
+              </a:rPr>
+              <a:t>3．不可能であれば72例で解析するか。可能であれば、72例を主解析とし、86例を感度分析として示すか。</a:t>
             </a:r>
           </a:p>
         </p:txBody>
@@ -3361,7 +3431,7 @@
                 <a:latin typeface="Yu Gothic"/>
                 <a:ea typeface="Yu Gothic"/>
               </a:rPr>
-              <a:t>2</a:t>
+              <a:t>10</a:t>
             </a:r>
           </a:p>
         </p:txBody>
@@ -3374,8 +3444,8 @@
 </p:sld>
 </file>
 
-<file path=ppt/slides/slide3.xml><?xml version="1.0" encoding="utf-8"?>
-<p:sld xmlns:a="http://schemas.openxmlformats.org/drawingml/2006/main" xmlns:p="http://schemas.openxmlformats.org/presentationml/2006/main" xmlns:r="http://schemas.openxmlformats.org/officeDocument/2006/relationships">
+<file path=ppt/slides/slide2.xml><?xml version="1.0" encoding="utf-8"?>
+<p:sld xmlns:a="http://schemas.openxmlformats.org/drawingml/2006/main" xmlns:r="http://schemas.openxmlformats.org/officeDocument/2006/relationships" xmlns:p="http://schemas.openxmlformats.org/presentationml/2006/main">
   <p:cSld>
     <p:spTree>
       <p:nvGrpSpPr>
@@ -3383,7 +3453,14 @@
         <p:cNvGrpSpPr/>
         <p:nvPr/>
       </p:nvGrpSpPr>
-      <p:grpSpPr/>
+      <p:grpSpPr>
+        <a:xfrm>
+          <a:off x="0" y="0"/>
+          <a:ext cx="0" cy="0"/>
+          <a:chOff x="0" y="0"/>
+          <a:chExt cx="0" cy="0"/>
+        </a:xfrm>
+      </p:grpSpPr>
       <p:sp>
         <p:nvSpPr>
           <p:cNvPr id="2" name="TextBox 1"/>
@@ -3401,7 +3478,7 @@
           <a:noFill/>
         </p:spPr>
         <p:txBody>
-          <a:bodyPr wrap="square" anchor="b" lIns="0" rIns="0">
+          <a:bodyPr wrap="square" lIns="0" rIns="0" anchor="b">
             <a:spAutoFit/>
           </a:bodyPr>
           <a:lstStyle/>
@@ -3415,14 +3492,14 @@
               </a:spcAft>
             </a:pPr>
             <a:r>
-              <a:rPr sz="3200" b="0" lang="ja-JP" altLang="en-US">
+              <a:rPr lang="ja-JP" altLang="en-US" sz="3200" b="0">
                 <a:solidFill>
                   <a:srgbClr val="000000"/>
                 </a:solidFill>
                 <a:latin typeface="Yu Gothic"/>
                 <a:ea typeface="Yu Gothic"/>
               </a:rPr>
-              <a:t>研究計画書の適格基準との照合</a:t>
+              <a:t>現在の解析対象</a:t>
             </a:r>
           </a:p>
         </p:txBody>
@@ -3444,7 +3521,7 @@
           <a:noFill/>
         </p:spPr>
         <p:txBody>
-          <a:bodyPr wrap="square" anchor="t" lIns="0" rIns="0">
+          <a:bodyPr wrap="square" lIns="0" rIns="0" anchor="t">
             <a:spAutoFit/>
           </a:bodyPr>
           <a:lstStyle/>
@@ -3458,14 +3535,14 @@
               </a:spcAft>
             </a:pPr>
             <a:r>
-              <a:rPr sz="2200" b="0" lang="ja-JP" altLang="en-US">
+              <a:rPr lang="ja-JP" altLang="en-US" sz="2200" b="0">
                 <a:solidFill>
                   <a:srgbClr val="000000"/>
                 </a:solidFill>
                 <a:latin typeface="Yu Gothic"/>
                 <a:ea typeface="Yu Gothic"/>
               </a:rPr>
-              <a:t>研究計画書（第2版・第3版）は、初診時年齢20歳以上80歳未満、2010年6月1日から2022年5月31日の手術例を対象としている。</a:t>
+              <a:t>期間中に膵癌で切除術を受けた106例のうち、術前治療の内容が異なる8例、組織切片が入手できなかった8例、浸潤性膵管癌以外の組織型であった4例を除外した。</a:t>
             </a:r>
           </a:p>
           <a:p>
@@ -3478,14 +3555,14 @@
               </a:spcAft>
             </a:pPr>
             <a:r>
-              <a:rPr sz="2200" b="0" lang="ja-JP" altLang="en-US">
+              <a:rPr lang="ja-JP" altLang="en-US" sz="2200" b="0">
                 <a:solidFill>
                   <a:srgbClr val="000000"/>
                 </a:solidFill>
                 <a:latin typeface="Yu Gothic"/>
                 <a:ea typeface="Yu Gothic"/>
               </a:rPr>
-              <a:t>手術単独群62例のうち、初診時80～84歳の12例と、2010年5月に手術を受けた2例が基準に該当しなかった。年齢と手術日はカルテで確認した。</a:t>
+              <a:t>解析対象は86例（NACRT群24例、手術単独群62例）である。SF055はカルテでNACRT施行を確認し、NACRT群に含めた。</a:t>
             </a:r>
           </a:p>
         </p:txBody>
@@ -3507,7 +3584,7 @@
           <a:noFill/>
         </p:spPr>
         <p:txBody>
-          <a:bodyPr wrap="square" anchor="t" lIns="0" rIns="0">
+          <a:bodyPr wrap="square" lIns="0" rIns="0" anchor="t">
             <a:spAutoFit/>
           </a:bodyPr>
           <a:lstStyle/>
@@ -3521,14 +3598,14 @@
               </a:spcAft>
             </a:pPr>
             <a:r>
-              <a:rPr sz="1200" b="0" lang="ja-JP" altLang="en-US">
+              <a:rPr lang="ja-JP" altLang="en-US" sz="1200" b="0">
                 <a:solidFill>
                   <a:srgbClr val="000000"/>
                 </a:solidFill>
                 <a:latin typeface="Yu Gothic"/>
                 <a:ea typeface="Yu Gothic"/>
               </a:rPr>
-              <a:t>3</a:t>
+              <a:t>2</a:t>
             </a:r>
           </a:p>
         </p:txBody>
@@ -3541,8 +3618,8 @@
 </p:sld>
 </file>
 
-<file path=ppt/slides/slide4.xml><?xml version="1.0" encoding="utf-8"?>
-<p:sld xmlns:a="http://schemas.openxmlformats.org/drawingml/2006/main" xmlns:p="http://schemas.openxmlformats.org/presentationml/2006/main" xmlns:r="http://schemas.openxmlformats.org/officeDocument/2006/relationships">
+<file path=ppt/slides/slide3.xml><?xml version="1.0" encoding="utf-8"?>
+<p:sld xmlns:a="http://schemas.openxmlformats.org/drawingml/2006/main" xmlns:r="http://schemas.openxmlformats.org/officeDocument/2006/relationships" xmlns:p="http://schemas.openxmlformats.org/presentationml/2006/main">
   <p:cSld>
     <p:spTree>
       <p:nvGrpSpPr>
@@ -3550,7 +3627,14 @@
         <p:cNvGrpSpPr/>
         <p:nvPr/>
       </p:nvGrpSpPr>
-      <p:grpSpPr/>
+      <p:grpSpPr>
+        <a:xfrm>
+          <a:off x="0" y="0"/>
+          <a:ext cx="0" cy="0"/>
+          <a:chOff x="0" y="0"/>
+          <a:chExt cx="0" cy="0"/>
+        </a:xfrm>
+      </p:grpSpPr>
       <p:sp>
         <p:nvSpPr>
           <p:cNvPr id="2" name="TextBox 1"/>
@@ -3568,7 +3652,7 @@
           <a:noFill/>
         </p:spPr>
         <p:txBody>
-          <a:bodyPr wrap="square" anchor="b" lIns="0" rIns="0">
+          <a:bodyPr wrap="square" lIns="0" rIns="0" anchor="b">
             <a:spAutoFit/>
           </a:bodyPr>
           <a:lstStyle/>
@@ -3582,14 +3666,14 @@
               </a:spcAft>
             </a:pPr>
             <a:r>
-              <a:rPr sz="3200" b="0" lang="ja-JP" altLang="en-US">
+              <a:rPr lang="ja-JP" altLang="en-US" sz="3200" b="0">
                 <a:solidFill>
                   <a:srgbClr val="000000"/>
                 </a:solidFill>
                 <a:latin typeface="Yu Gothic"/>
                 <a:ea typeface="Yu Gothic"/>
               </a:rPr>
-              <a:t>経緯</a:t>
+              <a:t>研究計画書の適格基準との照合</a:t>
             </a:r>
           </a:p>
         </p:txBody>
@@ -3611,7 +3695,7 @@
           <a:noFill/>
         </p:spPr>
         <p:txBody>
-          <a:bodyPr wrap="square" anchor="t" lIns="0" rIns="0">
+          <a:bodyPr wrap="square" lIns="0" rIns="0" anchor="t">
             <a:spAutoFit/>
           </a:bodyPr>
           <a:lstStyle/>
@@ -3625,14 +3709,14 @@
               </a:spcAft>
             </a:pPr>
             <a:r>
-              <a:rPr sz="2200" b="0" lang="ja-JP" altLang="en-US">
+              <a:rPr lang="ja-JP" altLang="en-US" sz="2200" b="0">
                 <a:solidFill>
                   <a:srgbClr val="000000"/>
                 </a:solidFill>
                 <a:latin typeface="Yu Gothic"/>
                 <a:ea typeface="Yu Gothic"/>
               </a:rPr>
-              <a:t>対象症例の一覧は前任者が作成した。作成時に年齢と手術期間の基準は適用されていなかったと考えられる。</a:t>
+              <a:t>研究計画書（第2版・第3版）は、初診時年齢20歳以上80歳未満、2010年6月1日から2022年5月31日の手術例を対象としている。</a:t>
             </a:r>
           </a:p>
           <a:p>
@@ -3645,34 +3729,14 @@
               </a:spcAft>
             </a:pPr>
             <a:r>
-              <a:rPr sz="2200" b="0" lang="ja-JP" altLang="en-US">
+              <a:rPr lang="ja-JP" altLang="en-US" sz="2200" b="0">
                 <a:solidFill>
                   <a:srgbClr val="000000"/>
                 </a:solidFill>
                 <a:latin typeface="Yu Gothic"/>
                 <a:ea typeface="Yu Gothic"/>
               </a:rPr>
-              <a:t>研究実施状況報告書では87例を登録し、計画書からの逸脱は無と報告している。</a:t>
-            </a:r>
-          </a:p>
-          <a:p>
-            <a:pPr algn="l" eaLnBrk="1" hangingPunct="1">
-              <a:lnSpc>
-                <a:spcPct val="130000"/>
-              </a:lnSpc>
-              <a:spcAft>
-                <a:spcPts val="1800"/>
-              </a:spcAft>
-            </a:pPr>
-            <a:r>
-              <a:rPr sz="2200" b="0" lang="ja-JP" altLang="en-US">
-                <a:solidFill>
-                  <a:srgbClr val="000000"/>
-                </a:solidFill>
-                <a:latin typeface="Yu Gothic"/>
-                <a:ea typeface="Yu Gothic"/>
-              </a:rPr>
-              <a:t>第1版（2020年の承認時）の研究計画書は手元になく、基準の内容は確認できていない。</a:t>
+              <a:t>手術単独群62例のうち、初診時80～84歳の12例と、2010年5月に手術を受けた2例が基準に該当しなかった。年齢と手術日はカルテで確認した。</a:t>
             </a:r>
           </a:p>
         </p:txBody>
@@ -3694,7 +3758,7 @@
           <a:noFill/>
         </p:spPr>
         <p:txBody>
-          <a:bodyPr wrap="square" anchor="t" lIns="0" rIns="0">
+          <a:bodyPr wrap="square" lIns="0" rIns="0" anchor="t">
             <a:spAutoFit/>
           </a:bodyPr>
           <a:lstStyle/>
@@ -3708,14 +3772,14 @@
               </a:spcAft>
             </a:pPr>
             <a:r>
-              <a:rPr sz="1200" b="0" lang="ja-JP" altLang="en-US">
+              <a:rPr lang="ja-JP" altLang="en-US" sz="1200" b="0">
                 <a:solidFill>
                   <a:srgbClr val="000000"/>
                 </a:solidFill>
                 <a:latin typeface="Yu Gothic"/>
                 <a:ea typeface="Yu Gothic"/>
               </a:rPr>
-              <a:t>4</a:t>
+              <a:t>3</a:t>
             </a:r>
           </a:p>
         </p:txBody>
@@ -3728,8 +3792,8 @@
 </p:sld>
 </file>
 
-<file path=ppt/slides/slide5.xml><?xml version="1.0" encoding="utf-8"?>
-<p:sld xmlns:a="http://schemas.openxmlformats.org/drawingml/2006/main" xmlns:p="http://schemas.openxmlformats.org/presentationml/2006/main" xmlns:r="http://schemas.openxmlformats.org/officeDocument/2006/relationships">
+<file path=ppt/slides/slide4.xml><?xml version="1.0" encoding="utf-8"?>
+<p:sld xmlns:a="http://schemas.openxmlformats.org/drawingml/2006/main" xmlns:r="http://schemas.openxmlformats.org/officeDocument/2006/relationships" xmlns:p="http://schemas.openxmlformats.org/presentationml/2006/main">
   <p:cSld>
     <p:spTree>
       <p:nvGrpSpPr>
@@ -3737,7 +3801,14 @@
         <p:cNvGrpSpPr/>
         <p:nvPr/>
       </p:nvGrpSpPr>
-      <p:grpSpPr/>
+      <p:grpSpPr>
+        <a:xfrm>
+          <a:off x="0" y="0"/>
+          <a:ext cx="0" cy="0"/>
+          <a:chOff x="0" y="0"/>
+          <a:chExt cx="0" cy="0"/>
+        </a:xfrm>
+      </p:grpSpPr>
       <p:sp>
         <p:nvSpPr>
           <p:cNvPr id="2" name="TextBox 1"/>
@@ -3755,7 +3826,7 @@
           <a:noFill/>
         </p:spPr>
         <p:txBody>
-          <a:bodyPr wrap="square" anchor="b" lIns="0" rIns="0">
+          <a:bodyPr wrap="square" lIns="0" rIns="0" anchor="b">
             <a:spAutoFit/>
           </a:bodyPr>
           <a:lstStyle/>
@@ -3769,7 +3840,228 @@
               </a:spcAft>
             </a:pPr>
             <a:r>
-              <a:rPr sz="3200" b="0" lang="ja-JP" altLang="en-US">
+              <a:rPr lang="ja-JP" altLang="en-US" sz="3200" b="0">
+                <a:solidFill>
+                  <a:srgbClr val="000000"/>
+                </a:solidFill>
+                <a:latin typeface="Yu Gothic"/>
+                <a:ea typeface="Yu Gothic"/>
+              </a:rPr>
+              <a:t>経緯</a:t>
+            </a:r>
+          </a:p>
+        </p:txBody>
+      </p:sp>
+      <p:sp>
+        <p:nvSpPr>
+          <p:cNvPr id="3" name="TextBox 2"/>
+          <p:cNvSpPr txBox="1"/>
+          <p:nvPr/>
+        </p:nvSpPr>
+        <p:spPr>
+          <a:xfrm>
+            <a:off x="822960" y="1737360"/>
+            <a:ext cx="10515600" cy="2724079"/>
+          </a:xfrm>
+          <a:prstGeom prst="rect">
+            <a:avLst/>
+          </a:prstGeom>
+          <a:noFill/>
+        </p:spPr>
+        <p:txBody>
+          <a:bodyPr wrap="square" lIns="0" rIns="0" anchor="t">
+            <a:spAutoFit/>
+          </a:bodyPr>
+          <a:lstStyle/>
+          <a:p>
+            <a:pPr algn="l" eaLnBrk="1" hangingPunct="1">
+              <a:lnSpc>
+                <a:spcPct val="130000"/>
+              </a:lnSpc>
+              <a:spcAft>
+                <a:spcPts val="1800"/>
+              </a:spcAft>
+            </a:pPr>
+            <a:r>
+              <a:rPr lang="ja-JP" altLang="en-US" sz="2200" b="0" dirty="0">
+                <a:solidFill>
+                  <a:srgbClr val="000000"/>
+                </a:solidFill>
+                <a:latin typeface="Yu Gothic"/>
+                <a:ea typeface="Yu Gothic"/>
+              </a:rPr>
+              <a:t>対象症例の一覧は竹原先生が作成したと思う。作成時に年齢と手術期間の基準は適用されていなかった</a:t>
+            </a:r>
+            <a:r>
+              <a:rPr lang="ja-JP" altLang="en-US" sz="2200" dirty="0">
+                <a:solidFill>
+                  <a:srgbClr val="000000"/>
+                </a:solidFill>
+                <a:latin typeface="Yu Gothic"/>
+                <a:ea typeface="Yu Gothic"/>
+              </a:rPr>
+              <a:t>？？</a:t>
+            </a:r>
+            <a:endParaRPr lang="ja-JP" altLang="en-US" sz="2200" b="0" dirty="0">
+              <a:solidFill>
+                <a:srgbClr val="000000"/>
+              </a:solidFill>
+              <a:latin typeface="Yu Gothic"/>
+              <a:ea typeface="Yu Gothic"/>
+            </a:endParaRPr>
+          </a:p>
+          <a:p>
+            <a:pPr algn="l" eaLnBrk="1" hangingPunct="1">
+              <a:lnSpc>
+                <a:spcPct val="130000"/>
+              </a:lnSpc>
+              <a:spcAft>
+                <a:spcPts val="1800"/>
+              </a:spcAft>
+            </a:pPr>
+            <a:r>
+              <a:rPr lang="ja-JP" altLang="en-US" sz="2200" b="0" dirty="0">
+                <a:solidFill>
+                  <a:srgbClr val="000000"/>
+                </a:solidFill>
+                <a:latin typeface="Yu Gothic"/>
+                <a:ea typeface="Yu Gothic"/>
+              </a:rPr>
+              <a:t>研究実施状況報告書では87例を登録し、計画書からの逸脱は無と報告している。</a:t>
+            </a:r>
+          </a:p>
+          <a:p>
+            <a:pPr algn="l" eaLnBrk="1" hangingPunct="1">
+              <a:lnSpc>
+                <a:spcPct val="130000"/>
+              </a:lnSpc>
+              <a:spcAft>
+                <a:spcPts val="1800"/>
+              </a:spcAft>
+            </a:pPr>
+            <a:r>
+              <a:rPr lang="en-US" altLang="ja-JP" sz="2200" b="0" dirty="0">
+                <a:solidFill>
+                  <a:srgbClr val="000000"/>
+                </a:solidFill>
+                <a:latin typeface="Yu Gothic"/>
+                <a:ea typeface="Yu Gothic"/>
+              </a:rPr>
+              <a:t>※</a:t>
+            </a:r>
+            <a:r>
+              <a:rPr lang="ja-JP" altLang="en-US" sz="2200" b="0" dirty="0">
+                <a:solidFill>
+                  <a:srgbClr val="000000"/>
+                </a:solidFill>
+                <a:latin typeface="Yu Gothic"/>
+                <a:ea typeface="Yu Gothic"/>
+              </a:rPr>
+              <a:t>第1版（2020年の承認時）の研究計画書は手元になく、基準の内容は確認できていない。</a:t>
+            </a:r>
+          </a:p>
+        </p:txBody>
+      </p:sp>
+      <p:sp>
+        <p:nvSpPr>
+          <p:cNvPr id="4" name="TextBox 3"/>
+          <p:cNvSpPr txBox="1"/>
+          <p:nvPr/>
+        </p:nvSpPr>
+        <p:spPr>
+          <a:xfrm>
+            <a:off x="10881360" y="6263640"/>
+            <a:ext cx="457200" cy="365760"/>
+          </a:xfrm>
+          <a:prstGeom prst="rect">
+            <a:avLst/>
+          </a:prstGeom>
+          <a:noFill/>
+        </p:spPr>
+        <p:txBody>
+          <a:bodyPr wrap="square" lIns="0" rIns="0" anchor="t">
+            <a:spAutoFit/>
+          </a:bodyPr>
+          <a:lstStyle/>
+          <a:p>
+            <a:pPr algn="r" eaLnBrk="1" hangingPunct="1">
+              <a:lnSpc>
+                <a:spcPct val="130000"/>
+              </a:lnSpc>
+              <a:spcAft>
+                <a:spcPts val="1000"/>
+              </a:spcAft>
+            </a:pPr>
+            <a:r>
+              <a:rPr lang="ja-JP" altLang="en-US" sz="1200" b="0">
+                <a:solidFill>
+                  <a:srgbClr val="000000"/>
+                </a:solidFill>
+                <a:latin typeface="Yu Gothic"/>
+                <a:ea typeface="Yu Gothic"/>
+              </a:rPr>
+              <a:t>4</a:t>
+            </a:r>
+          </a:p>
+        </p:txBody>
+      </p:sp>
+    </p:spTree>
+  </p:cSld>
+  <p:clrMapOvr>
+    <a:masterClrMapping/>
+  </p:clrMapOvr>
+</p:sld>
+</file>
+
+<file path=ppt/slides/slide5.xml><?xml version="1.0" encoding="utf-8"?>
+<p:sld xmlns:a="http://schemas.openxmlformats.org/drawingml/2006/main" xmlns:r="http://schemas.openxmlformats.org/officeDocument/2006/relationships" xmlns:p="http://schemas.openxmlformats.org/presentationml/2006/main">
+  <p:cSld>
+    <p:spTree>
+      <p:nvGrpSpPr>
+        <p:cNvPr id="1" name=""/>
+        <p:cNvGrpSpPr/>
+        <p:nvPr/>
+      </p:nvGrpSpPr>
+      <p:grpSpPr>
+        <a:xfrm>
+          <a:off x="0" y="0"/>
+          <a:ext cx="0" cy="0"/>
+          <a:chOff x="0" y="0"/>
+          <a:chExt cx="0" cy="0"/>
+        </a:xfrm>
+      </p:grpSpPr>
+      <p:sp>
+        <p:nvSpPr>
+          <p:cNvPr id="2" name="TextBox 1"/>
+          <p:cNvSpPr txBox="1"/>
+          <p:nvPr/>
+        </p:nvSpPr>
+        <p:spPr>
+          <a:xfrm>
+            <a:off x="822960" y="548640"/>
+            <a:ext cx="10515600" cy="822960"/>
+          </a:xfrm>
+          <a:prstGeom prst="rect">
+            <a:avLst/>
+          </a:prstGeom>
+          <a:noFill/>
+        </p:spPr>
+        <p:txBody>
+          <a:bodyPr wrap="square" lIns="0" rIns="0" anchor="b">
+            <a:spAutoFit/>
+          </a:bodyPr>
+          <a:lstStyle/>
+          <a:p>
+            <a:pPr algn="l" eaLnBrk="1" hangingPunct="1">
+              <a:lnSpc>
+                <a:spcPct val="130000"/>
+              </a:lnSpc>
+              <a:spcAft>
+                <a:spcPts val="1000"/>
+              </a:spcAft>
+            </a:pPr>
+            <a:r>
+              <a:rPr lang="ja-JP" altLang="en-US" sz="3200" b="0">
                 <a:solidFill>
                   <a:srgbClr val="000000"/>
                 </a:solidFill>
@@ -3798,7 +4090,7 @@
           <a:noFill/>
         </p:spPr>
         <p:txBody>
-          <a:bodyPr wrap="square" anchor="t" lIns="0" rIns="0">
+          <a:bodyPr wrap="square" lIns="0" rIns="0" anchor="t">
             <a:spAutoFit/>
           </a:bodyPr>
           <a:lstStyle/>
@@ -3812,7 +4104,7 @@
               </a:spcAft>
             </a:pPr>
             <a:r>
-              <a:rPr sz="2200" b="0" lang="ja-JP" altLang="en-US">
+              <a:rPr lang="ja-JP" altLang="en-US" sz="2200" b="0">
                 <a:solidFill>
                   <a:srgbClr val="000000"/>
                 </a:solidFill>
@@ -3832,7 +4124,7 @@
               </a:spcAft>
             </a:pPr>
             <a:r>
-              <a:rPr sz="2200" b="0" lang="ja-JP" altLang="en-US">
+              <a:rPr lang="ja-JP" altLang="en-US" sz="2200" b="0">
                 <a:solidFill>
                   <a:srgbClr val="000000"/>
                 </a:solidFill>
@@ -3861,7 +4153,7 @@
           <a:noFill/>
         </p:spPr>
         <p:txBody>
-          <a:bodyPr wrap="square" anchor="t" lIns="0" rIns="0">
+          <a:bodyPr wrap="square" lIns="0" rIns="0" anchor="t">
             <a:spAutoFit/>
           </a:bodyPr>
           <a:lstStyle/>
@@ -3875,7 +4167,7 @@
               </a:spcAft>
             </a:pPr>
             <a:r>
-              <a:rPr sz="1200" b="0" lang="ja-JP" altLang="en-US">
+              <a:rPr lang="ja-JP" altLang="en-US" sz="1200" b="0">
                 <a:solidFill>
                   <a:srgbClr val="000000"/>
                 </a:solidFill>
@@ -3896,7 +4188,7 @@
 </file>
 
 <file path=ppt/slides/slide6.xml><?xml version="1.0" encoding="utf-8"?>
-<p:sld xmlns:a="http://schemas.openxmlformats.org/drawingml/2006/main" xmlns:p="http://schemas.openxmlformats.org/presentationml/2006/main" xmlns:r="http://schemas.openxmlformats.org/officeDocument/2006/relationships">
+<p:sld xmlns:a="http://schemas.openxmlformats.org/drawingml/2006/main" xmlns:r="http://schemas.openxmlformats.org/officeDocument/2006/relationships" xmlns:p="http://schemas.openxmlformats.org/presentationml/2006/main">
   <p:cSld>
     <p:spTree>
       <p:nvGrpSpPr>
@@ -3904,7 +4196,14 @@
         <p:cNvGrpSpPr/>
         <p:nvPr/>
       </p:nvGrpSpPr>
-      <p:grpSpPr/>
+      <p:grpSpPr>
+        <a:xfrm>
+          <a:off x="0" y="0"/>
+          <a:ext cx="0" cy="0"/>
+          <a:chOff x="0" y="0"/>
+          <a:chExt cx="0" cy="0"/>
+        </a:xfrm>
+      </p:grpSpPr>
       <p:sp>
         <p:nvSpPr>
           <p:cNvPr id="2" name="TextBox 1"/>
@@ -3922,7 +4221,7 @@
           <a:noFill/>
         </p:spPr>
         <p:txBody>
-          <a:bodyPr wrap="square" anchor="b" lIns="0" rIns="0">
+          <a:bodyPr wrap="square" lIns="0" rIns="0" anchor="b">
             <a:spAutoFit/>
           </a:bodyPr>
           <a:lstStyle/>
@@ -3936,7 +4235,7 @@
               </a:spcAft>
             </a:pPr>
             <a:r>
-              <a:rPr sz="3200" b="0" lang="ja-JP" altLang="en-US">
+              <a:rPr lang="ja-JP" altLang="en-US" sz="3200" b="0">
                 <a:solidFill>
                   <a:srgbClr val="000000"/>
                 </a:solidFill>
@@ -3944,6 +4243,307 @@
                 <a:ea typeface="Yu Gothic"/>
               </a:rPr>
               <a:t>ご相談したいこと</a:t>
+            </a:r>
+          </a:p>
+        </p:txBody>
+      </p:sp>
+      <p:sp>
+        <p:nvSpPr>
+          <p:cNvPr id="3" name="TextBox 2"/>
+          <p:cNvSpPr txBox="1"/>
+          <p:nvPr/>
+        </p:nvSpPr>
+        <p:spPr>
+          <a:xfrm>
+            <a:off x="822960" y="1737360"/>
+            <a:ext cx="10515600" cy="3395032"/>
+          </a:xfrm>
+          <a:prstGeom prst="rect">
+            <a:avLst/>
+          </a:prstGeom>
+          <a:noFill/>
+        </p:spPr>
+        <p:txBody>
+          <a:bodyPr wrap="square" lIns="0" rIns="0" anchor="t">
+            <a:spAutoFit/>
+          </a:bodyPr>
+          <a:lstStyle/>
+          <a:p>
+            <a:pPr algn="l" eaLnBrk="1" hangingPunct="1">
+              <a:lnSpc>
+                <a:spcPct val="130000"/>
+              </a:lnSpc>
+              <a:spcAft>
+                <a:spcPts val="1800"/>
+              </a:spcAft>
+            </a:pPr>
+            <a:r>
+              <a:rPr lang="ja-JP" altLang="en-US" sz="2200" b="0" dirty="0">
+                <a:solidFill>
+                  <a:srgbClr val="000000"/>
+                </a:solidFill>
+                <a:latin typeface="Yu Gothic"/>
+                <a:ea typeface="Yu Gothic"/>
+              </a:rPr>
+              <a:t>1．第1版の研究計画書の年齢基準と手術期間は、現行版と同じか。</a:t>
+            </a:r>
+            <a:endParaRPr lang="en-US" altLang="ja-JP" sz="2200" b="0" dirty="0">
+              <a:solidFill>
+                <a:srgbClr val="000000"/>
+              </a:solidFill>
+              <a:latin typeface="Yu Gothic"/>
+              <a:ea typeface="Yu Gothic"/>
+            </a:endParaRPr>
+          </a:p>
+          <a:p>
+            <a:pPr algn="l" eaLnBrk="1" hangingPunct="1">
+              <a:lnSpc>
+                <a:spcPct val="130000"/>
+              </a:lnSpc>
+              <a:spcAft>
+                <a:spcPts val="1800"/>
+              </a:spcAft>
+            </a:pPr>
+            <a:r>
+              <a:rPr lang="ja-JP" altLang="en-US" sz="2200" dirty="0">
+                <a:solidFill>
+                  <a:srgbClr val="000000"/>
+                </a:solidFill>
+                <a:latin typeface="Yu Gothic"/>
+                <a:ea typeface="Yu Gothic"/>
+              </a:rPr>
+              <a:t>　</a:t>
+            </a:r>
+            <a:r>
+              <a:rPr lang="en-US" altLang="ja-JP" sz="2200" dirty="0">
+                <a:solidFill>
+                  <a:srgbClr val="000000"/>
+                </a:solidFill>
+                <a:latin typeface="Yu Gothic"/>
+                <a:ea typeface="Yu Gothic"/>
+              </a:rPr>
+              <a:t>※</a:t>
+            </a:r>
+            <a:r>
+              <a:rPr lang="ja-JP" altLang="en-US" sz="2200" dirty="0">
+                <a:solidFill>
+                  <a:srgbClr val="000000"/>
+                </a:solidFill>
+                <a:latin typeface="Yu Gothic"/>
+                <a:ea typeface="Yu Gothic"/>
+              </a:rPr>
+              <a:t>第</a:t>
+            </a:r>
+            <a:r>
+              <a:rPr lang="en-US" altLang="ja-JP" sz="2200" dirty="0">
+                <a:solidFill>
+                  <a:srgbClr val="000000"/>
+                </a:solidFill>
+                <a:latin typeface="Yu Gothic"/>
+                <a:ea typeface="Yu Gothic"/>
+              </a:rPr>
+              <a:t>2</a:t>
+            </a:r>
+            <a:r>
+              <a:rPr lang="ja-JP" altLang="en-US" sz="2200" dirty="0">
+                <a:solidFill>
+                  <a:srgbClr val="000000"/>
+                </a:solidFill>
+                <a:latin typeface="Yu Gothic"/>
+                <a:ea typeface="Yu Gothic"/>
+              </a:rPr>
+              <a:t>版の年齢基準には「第</a:t>
+            </a:r>
+            <a:r>
+              <a:rPr lang="en-US" altLang="ja-JP" sz="2200" dirty="0">
+                <a:solidFill>
+                  <a:srgbClr val="000000"/>
+                </a:solidFill>
+                <a:latin typeface="Yu Gothic"/>
+                <a:ea typeface="Yu Gothic"/>
+              </a:rPr>
+              <a:t>1</a:t>
+            </a:r>
+            <a:r>
+              <a:rPr lang="ja-JP" altLang="en-US" sz="2200" dirty="0">
+                <a:solidFill>
+                  <a:srgbClr val="000000"/>
+                </a:solidFill>
+                <a:latin typeface="Yu Gothic"/>
+                <a:ea typeface="Yu Gothic"/>
+              </a:rPr>
+              <a:t>版から</a:t>
+            </a:r>
+            <a:r>
+              <a:rPr lang="ja-JP" altLang="en-US" sz="2200">
+                <a:solidFill>
+                  <a:srgbClr val="000000"/>
+                </a:solidFill>
+                <a:latin typeface="Yu Gothic"/>
+                <a:ea typeface="Yu Gothic"/>
+              </a:rPr>
+              <a:t>の変更あり」</a:t>
+            </a:r>
+            <a:r>
+              <a:rPr lang="ja-JP" altLang="en-US" sz="2200" dirty="0">
+                <a:solidFill>
+                  <a:srgbClr val="000000"/>
+                </a:solidFill>
+                <a:latin typeface="Yu Gothic"/>
+                <a:ea typeface="Yu Gothic"/>
+              </a:rPr>
+              <a:t>と書かれていないため基準の変更はなかったと思われる。</a:t>
+            </a:r>
+            <a:endParaRPr lang="ja-JP" altLang="en-US" sz="2200" b="0" dirty="0">
+              <a:solidFill>
+                <a:srgbClr val="000000"/>
+              </a:solidFill>
+              <a:latin typeface="Yu Gothic"/>
+              <a:ea typeface="Yu Gothic"/>
+            </a:endParaRPr>
+          </a:p>
+          <a:p>
+            <a:pPr algn="l" eaLnBrk="1" hangingPunct="1">
+              <a:lnSpc>
+                <a:spcPct val="130000"/>
+              </a:lnSpc>
+              <a:spcAft>
+                <a:spcPts val="1800"/>
+              </a:spcAft>
+            </a:pPr>
+            <a:r>
+              <a:rPr lang="ja-JP" altLang="en-US" sz="2200" b="0" dirty="0">
+                <a:solidFill>
+                  <a:srgbClr val="000000"/>
+                </a:solidFill>
+                <a:latin typeface="Yu Gothic"/>
+                <a:ea typeface="Yu Gothic"/>
+              </a:rPr>
+              <a:t>2．同じであれば、AとBのいずれで進めるか。</a:t>
+            </a:r>
+          </a:p>
+          <a:p>
+            <a:pPr algn="l" eaLnBrk="1" hangingPunct="1">
+              <a:lnSpc>
+                <a:spcPct val="130000"/>
+              </a:lnSpc>
+              <a:spcAft>
+                <a:spcPts val="1800"/>
+              </a:spcAft>
+            </a:pPr>
+            <a:r>
+              <a:rPr lang="ja-JP" altLang="en-US" sz="2200" b="0" dirty="0">
+                <a:solidFill>
+                  <a:srgbClr val="000000"/>
+                </a:solidFill>
+                <a:latin typeface="Yu Gothic"/>
+                <a:ea typeface="Yu Gothic"/>
+              </a:rPr>
+              <a:t>3．再計算は、第二評価者との合議で最終値が確定した後に、まとめて行う予定でよいか。</a:t>
+            </a:r>
+          </a:p>
+        </p:txBody>
+      </p:sp>
+      <p:sp>
+        <p:nvSpPr>
+          <p:cNvPr id="4" name="TextBox 3"/>
+          <p:cNvSpPr txBox="1"/>
+          <p:nvPr/>
+        </p:nvSpPr>
+        <p:spPr>
+          <a:xfrm>
+            <a:off x="10881360" y="6263640"/>
+            <a:ext cx="457200" cy="365760"/>
+          </a:xfrm>
+          <a:prstGeom prst="rect">
+            <a:avLst/>
+          </a:prstGeom>
+          <a:noFill/>
+        </p:spPr>
+        <p:txBody>
+          <a:bodyPr wrap="square" lIns="0" rIns="0" anchor="t">
+            <a:spAutoFit/>
+          </a:bodyPr>
+          <a:lstStyle/>
+          <a:p>
+            <a:pPr algn="r" eaLnBrk="1" hangingPunct="1">
+              <a:lnSpc>
+                <a:spcPct val="130000"/>
+              </a:lnSpc>
+              <a:spcAft>
+                <a:spcPts val="1000"/>
+              </a:spcAft>
+            </a:pPr>
+            <a:r>
+              <a:rPr lang="ja-JP" altLang="en-US" sz="1200" b="0">
+                <a:solidFill>
+                  <a:srgbClr val="000000"/>
+                </a:solidFill>
+                <a:latin typeface="Yu Gothic"/>
+                <a:ea typeface="Yu Gothic"/>
+              </a:rPr>
+              <a:t>6</a:t>
+            </a:r>
+          </a:p>
+        </p:txBody>
+      </p:sp>
+    </p:spTree>
+  </p:cSld>
+  <p:clrMapOvr>
+    <a:masterClrMapping/>
+  </p:clrMapOvr>
+</p:sld>
+</file>
+
+<file path=ppt/slides/slide7.xml><?xml version="1.0" encoding="utf-8"?>
+<p:sld xmlns:a="http://schemas.openxmlformats.org/drawingml/2006/main" xmlns:p="http://schemas.openxmlformats.org/presentationml/2006/main" xmlns:r="http://schemas.openxmlformats.org/officeDocument/2006/relationships">
+  <p:cSld>
+    <p:spTree>
+      <p:nvGrpSpPr>
+        <p:cNvPr id="1" name=""/>
+        <p:cNvGrpSpPr/>
+        <p:nvPr/>
+      </p:nvGrpSpPr>
+      <p:grpSpPr/>
+      <p:sp>
+        <p:nvSpPr>
+          <p:cNvPr id="2" name="TextBox 1"/>
+          <p:cNvSpPr txBox="1"/>
+          <p:nvPr/>
+        </p:nvSpPr>
+        <p:spPr>
+          <a:xfrm>
+            <a:off x="822960" y="548640"/>
+            <a:ext cx="10515600" cy="822960"/>
+          </a:xfrm>
+          <a:prstGeom prst="rect">
+            <a:avLst/>
+          </a:prstGeom>
+          <a:noFill/>
+        </p:spPr>
+        <p:txBody>
+          <a:bodyPr wrap="square" anchor="b" lIns="0" rIns="0">
+            <a:spAutoFit/>
+          </a:bodyPr>
+          <a:lstStyle/>
+          <a:p>
+            <a:pPr algn="l" eaLnBrk="1" hangingPunct="1">
+              <a:lnSpc>
+                <a:spcPct val="130000"/>
+              </a:lnSpc>
+              <a:spcAft>
+                <a:spcPts val="1000"/>
+              </a:spcAft>
+            </a:pPr>
+            <a:r>
+              <a:rPr sz="3200" b="0" lang="ja-JP" altLang="en-US">
+                <a:solidFill>
+                  <a:srgbClr val="000000"/>
+                </a:solidFill>
+                <a:latin typeface="Yu Gothic"/>
+                <a:ea typeface="Yu Gothic"/>
+              </a:rPr>
+              <a:t>補足1　解析の目的と年齢の影響</a:t>
             </a:r>
           </a:p>
         </p:txBody>
@@ -3986,7 +4586,7 @@
                 <a:latin typeface="Yu Gothic"/>
                 <a:ea typeface="Yu Gothic"/>
               </a:rPr>
-              <a:t>1．第1版の研究計画書の年齢基準と手術期間は、現行版と同じか。</a:t>
+              <a:t>本研究の目的は免疫パラメータの比較であり、予後調査ではない。</a:t>
             </a:r>
           </a:p>
           <a:p>
@@ -4006,7 +4606,7 @@
                 <a:latin typeface="Yu Gothic"/>
                 <a:ea typeface="Yu Gothic"/>
               </a:rPr>
-              <a:t>2．同じであれば、AとBのいずれで進めるか。</a:t>
+              <a:t>一方、Hiraokaら（2020）は、膵癌で65歳以上の症例にHLA class Iの低発現が多いと報告している（p=0.002）。</a:t>
             </a:r>
           </a:p>
           <a:p>
@@ -4026,7 +4626,7 @@
                 <a:latin typeface="Yu Gothic"/>
                 <a:ea typeface="Yu Gothic"/>
               </a:rPr>
-              <a:t>3．再計算は、第二評価者との合議で最終値が確定した後に、まとめて行う予定でよいか。</a:t>
+              <a:t>基準外の12例はすべて手術単独群にあり、含めるかどうかで群間の年齢構成が変わる。</a:t>
             </a:r>
           </a:p>
         </p:txBody>
@@ -4069,7 +4669,341 @@
                 <a:latin typeface="Yu Gothic"/>
                 <a:ea typeface="Yu Gothic"/>
               </a:rPr>
-              <a:t>6</a:t>
+              <a:t>7</a:t>
+            </a:r>
+          </a:p>
+        </p:txBody>
+      </p:sp>
+    </p:spTree>
+  </p:cSld>
+  <p:clrMapOvr>
+    <a:masterClrMapping/>
+  </p:clrMapOvr>
+</p:sld>
+</file>
+
+<file path=ppt/slides/slide8.xml><?xml version="1.0" encoding="utf-8"?>
+<p:sld xmlns:a="http://schemas.openxmlformats.org/drawingml/2006/main" xmlns:p="http://schemas.openxmlformats.org/presentationml/2006/main" xmlns:r="http://schemas.openxmlformats.org/officeDocument/2006/relationships">
+  <p:cSld>
+    <p:spTree>
+      <p:nvGrpSpPr>
+        <p:cNvPr id="1" name=""/>
+        <p:cNvGrpSpPr/>
+        <p:nvPr/>
+      </p:nvGrpSpPr>
+      <p:grpSpPr/>
+      <p:sp>
+        <p:nvSpPr>
+          <p:cNvPr id="2" name="TextBox 1"/>
+          <p:cNvSpPr txBox="1"/>
+          <p:nvPr/>
+        </p:nvSpPr>
+        <p:spPr>
+          <a:xfrm>
+            <a:off x="822960" y="548640"/>
+            <a:ext cx="10515600" cy="822960"/>
+          </a:xfrm>
+          <a:prstGeom prst="rect">
+            <a:avLst/>
+          </a:prstGeom>
+          <a:noFill/>
+        </p:spPr>
+        <p:txBody>
+          <a:bodyPr wrap="square" anchor="b" lIns="0" rIns="0">
+            <a:spAutoFit/>
+          </a:bodyPr>
+          <a:lstStyle/>
+          <a:p>
+            <a:pPr algn="l" eaLnBrk="1" hangingPunct="1">
+              <a:lnSpc>
+                <a:spcPct val="130000"/>
+              </a:lnSpc>
+              <a:spcAft>
+                <a:spcPts val="1000"/>
+              </a:spcAft>
+            </a:pPr>
+            <a:r>
+              <a:rPr sz="3200" b="0" lang="ja-JP" altLang="en-US">
+                <a:solidFill>
+                  <a:srgbClr val="000000"/>
+                </a:solidFill>
+                <a:latin typeface="Yu Gothic"/>
+                <a:ea typeface="Yu Gothic"/>
+              </a:rPr>
+              <a:t>補足2　情報公開文書との関係</a:t>
+            </a:r>
+          </a:p>
+        </p:txBody>
+      </p:sp>
+      <p:sp>
+        <p:nvSpPr>
+          <p:cNvPr id="3" name="TextBox 2"/>
+          <p:cNvSpPr txBox="1"/>
+          <p:nvPr/>
+        </p:nvSpPr>
+        <p:spPr>
+          <a:xfrm>
+            <a:off x="822960" y="1737360"/>
+            <a:ext cx="10515600" cy="4480560"/>
+          </a:xfrm>
+          <a:prstGeom prst="rect">
+            <a:avLst/>
+          </a:prstGeom>
+          <a:noFill/>
+        </p:spPr>
+        <p:txBody>
+          <a:bodyPr wrap="square" anchor="t" lIns="0" rIns="0">
+            <a:spAutoFit/>
+          </a:bodyPr>
+          <a:lstStyle/>
+          <a:p>
+            <a:pPr algn="l" eaLnBrk="1" hangingPunct="1">
+              <a:lnSpc>
+                <a:spcPct val="130000"/>
+              </a:lnSpc>
+              <a:spcAft>
+                <a:spcPts val="1800"/>
+              </a:spcAft>
+            </a:pPr>
+            <a:r>
+              <a:rPr sz="2200" b="0" lang="ja-JP" altLang="en-US">
+                <a:solidFill>
+                  <a:srgbClr val="000000"/>
+                </a:solidFill>
+                <a:latin typeface="Yu Gothic"/>
+                <a:ea typeface="Yu Gothic"/>
+              </a:rPr>
+              <a:t>本研究はオプトアウトで実施している。情報公開文書の対象は、初診時20歳以上80歳未満、2010年6月から2022年5月の手術例である。</a:t>
+            </a:r>
+          </a:p>
+          <a:p>
+            <a:pPr algn="l" eaLnBrk="1" hangingPunct="1">
+              <a:lnSpc>
+                <a:spcPct val="130000"/>
+              </a:lnSpc>
+              <a:spcAft>
+                <a:spcPts val="1800"/>
+              </a:spcAft>
+            </a:pPr>
+            <a:r>
+              <a:rPr sz="2200" b="0" lang="ja-JP" altLang="en-US">
+                <a:solidFill>
+                  <a:srgbClr val="000000"/>
+                </a:solidFill>
+                <a:latin typeface="Yu Gothic"/>
+                <a:ea typeface="Yu Gothic"/>
+              </a:rPr>
+              <a:t>基準外の患者は対象に含まれておらず、参加を拒否する機会がなかった。論文で理由を説明するだけでは、承認範囲外のデータを用いた点は解消しない。</a:t>
+            </a:r>
+          </a:p>
+        </p:txBody>
+      </p:sp>
+      <p:sp>
+        <p:nvSpPr>
+          <p:cNvPr id="4" name="TextBox 3"/>
+          <p:cNvSpPr txBox="1"/>
+          <p:nvPr/>
+        </p:nvSpPr>
+        <p:spPr>
+          <a:xfrm>
+            <a:off x="10881360" y="6263640"/>
+            <a:ext cx="457200" cy="365760"/>
+          </a:xfrm>
+          <a:prstGeom prst="rect">
+            <a:avLst/>
+          </a:prstGeom>
+          <a:noFill/>
+        </p:spPr>
+        <p:txBody>
+          <a:bodyPr wrap="square" anchor="t" lIns="0" rIns="0">
+            <a:spAutoFit/>
+          </a:bodyPr>
+          <a:lstStyle/>
+          <a:p>
+            <a:pPr algn="r" eaLnBrk="1" hangingPunct="1">
+              <a:lnSpc>
+                <a:spcPct val="130000"/>
+              </a:lnSpc>
+              <a:spcAft>
+                <a:spcPts val="1000"/>
+              </a:spcAft>
+            </a:pPr>
+            <a:r>
+              <a:rPr sz="1200" b="0" lang="ja-JP" altLang="en-US">
+                <a:solidFill>
+                  <a:srgbClr val="000000"/>
+                </a:solidFill>
+                <a:latin typeface="Yu Gothic"/>
+                <a:ea typeface="Yu Gothic"/>
+              </a:rPr>
+              <a:t>8</a:t>
+            </a:r>
+          </a:p>
+        </p:txBody>
+      </p:sp>
+    </p:spTree>
+  </p:cSld>
+  <p:clrMapOvr>
+    <a:masterClrMapping/>
+  </p:clrMapOvr>
+</p:sld>
+</file>
+
+<file path=ppt/slides/slide9.xml><?xml version="1.0" encoding="utf-8"?>
+<p:sld xmlns:a="http://schemas.openxmlformats.org/drawingml/2006/main" xmlns:p="http://schemas.openxmlformats.org/presentationml/2006/main" xmlns:r="http://schemas.openxmlformats.org/officeDocument/2006/relationships">
+  <p:cSld>
+    <p:spTree>
+      <p:nvGrpSpPr>
+        <p:cNvPr id="1" name=""/>
+        <p:cNvGrpSpPr/>
+        <p:nvPr/>
+      </p:nvGrpSpPr>
+      <p:grpSpPr/>
+      <p:sp>
+        <p:nvSpPr>
+          <p:cNvPr id="2" name="TextBox 1"/>
+          <p:cNvSpPr txBox="1"/>
+          <p:nvPr/>
+        </p:nvSpPr>
+        <p:spPr>
+          <a:xfrm>
+            <a:off x="822960" y="548640"/>
+            <a:ext cx="10515600" cy="822960"/>
+          </a:xfrm>
+          <a:prstGeom prst="rect">
+            <a:avLst/>
+          </a:prstGeom>
+          <a:noFill/>
+        </p:spPr>
+        <p:txBody>
+          <a:bodyPr wrap="square" anchor="b" lIns="0" rIns="0">
+            <a:spAutoFit/>
+          </a:bodyPr>
+          <a:lstStyle/>
+          <a:p>
+            <a:pPr algn="l" eaLnBrk="1" hangingPunct="1">
+              <a:lnSpc>
+                <a:spcPct val="130000"/>
+              </a:lnSpc>
+              <a:spcAft>
+                <a:spcPts val="1000"/>
+              </a:spcAft>
+            </a:pPr>
+            <a:r>
+              <a:rPr sz="3200" b="0" lang="ja-JP" altLang="en-US">
+                <a:solidFill>
+                  <a:srgbClr val="000000"/>
+                </a:solidFill>
+                <a:latin typeface="Yu Gothic"/>
+                <a:ea typeface="Yu Gothic"/>
+              </a:rPr>
+              <a:t>補足3　計画との違いの報告</a:t>
+            </a:r>
+          </a:p>
+        </p:txBody>
+      </p:sp>
+      <p:sp>
+        <p:nvSpPr>
+          <p:cNvPr id="3" name="TextBox 2"/>
+          <p:cNvSpPr txBox="1"/>
+          <p:nvPr/>
+        </p:nvSpPr>
+        <p:spPr>
+          <a:xfrm>
+            <a:off x="822960" y="1737360"/>
+            <a:ext cx="10515600" cy="4480560"/>
+          </a:xfrm>
+          <a:prstGeom prst="rect">
+            <a:avLst/>
+          </a:prstGeom>
+          <a:noFill/>
+        </p:spPr>
+        <p:txBody>
+          <a:bodyPr wrap="square" anchor="t" lIns="0" rIns="0">
+            <a:spAutoFit/>
+          </a:bodyPr>
+          <a:lstStyle/>
+          <a:p>
+            <a:pPr algn="l" eaLnBrk="1" hangingPunct="1">
+              <a:lnSpc>
+                <a:spcPct val="130000"/>
+              </a:lnSpc>
+              <a:spcAft>
+                <a:spcPts val="1800"/>
+              </a:spcAft>
+            </a:pPr>
+            <a:r>
+              <a:rPr sz="2200" b="0" lang="ja-JP" altLang="en-US">
+                <a:solidFill>
+                  <a:srgbClr val="000000"/>
+                </a:solidFill>
+                <a:latin typeface="Yu Gothic"/>
+                <a:ea typeface="Yu Gothic"/>
+              </a:rPr>
+              <a:t>計画からの逸脱を理由とともに報告することは、臨床研究では通常の手続きである。</a:t>
+            </a:r>
+          </a:p>
+          <a:p>
+            <a:pPr algn="l" eaLnBrk="1" hangingPunct="1">
+              <a:lnSpc>
+                <a:spcPct val="130000"/>
+              </a:lnSpc>
+              <a:spcAft>
+                <a:spcPts val="1800"/>
+              </a:spcAft>
+            </a:pPr>
+            <a:r>
+              <a:rPr sz="2200" b="0" lang="ja-JP" altLang="en-US">
+                <a:solidFill>
+                  <a:srgbClr val="000000"/>
+                </a:solidFill>
+                <a:latin typeface="Yu Gothic"/>
+                <a:ea typeface="Yu Gothic"/>
+              </a:rPr>
+              <a:t>ただし、その前提は施設が逸脱を把握していることである。本研究の終了報告書は逸脱無としており、論文だけで説明すると施設への報告と食い違う。</a:t>
+            </a:r>
+          </a:p>
+        </p:txBody>
+      </p:sp>
+      <p:sp>
+        <p:nvSpPr>
+          <p:cNvPr id="4" name="TextBox 3"/>
+          <p:cNvSpPr txBox="1"/>
+          <p:nvPr/>
+        </p:nvSpPr>
+        <p:spPr>
+          <a:xfrm>
+            <a:off x="10881360" y="6263640"/>
+            <a:ext cx="457200" cy="365760"/>
+          </a:xfrm>
+          <a:prstGeom prst="rect">
+            <a:avLst/>
+          </a:prstGeom>
+          <a:noFill/>
+        </p:spPr>
+        <p:txBody>
+          <a:bodyPr wrap="square" anchor="t" lIns="0" rIns="0">
+            <a:spAutoFit/>
+          </a:bodyPr>
+          <a:lstStyle/>
+          <a:p>
+            <a:pPr algn="r" eaLnBrk="1" hangingPunct="1">
+              <a:lnSpc>
+                <a:spcPct val="130000"/>
+              </a:lnSpc>
+              <a:spcAft>
+                <a:spcPts val="1000"/>
+              </a:spcAft>
+            </a:pPr>
+            <a:r>
+              <a:rPr sz="1200" b="0" lang="ja-JP" altLang="en-US">
+                <a:solidFill>
+                  <a:srgbClr val="000000"/>
+                </a:solidFill>
+                <a:latin typeface="Yu Gothic"/>
+                <a:ea typeface="Yu Gothic"/>
+              </a:rPr>
+              <a:t>9</a:t>
             </a:r>
           </a:p>
         </p:txBody>

</xml_diff>